<commit_message>
Add narrated hackathon demo video and submission links
</commit_message>
<xml_diff>
--- a/docs/submission/AdVergent-pitch-deck.pptx
+++ b/docs/submission/AdVergent-pitch-deck.pptx
@@ -2,20 +2,20 @@
 <file path=ppt/presentation.xml><?xml version="1.0" encoding="utf-8"?>
 <p:presentation xmlns:p="http://schemas.openxmlformats.org/presentationml/2006/main">
   <p:sldMasterIdLst>
-    <p:sldMasterId xmlns:r="http://schemas.openxmlformats.org/officeDocument/2006/relationships" id="2147483648" r:id="R030a07c421834913"/>
+    <p:sldMasterId xmlns:r="http://schemas.openxmlformats.org/officeDocument/2006/relationships" id="2147483648" r:id="Ra9b73d6b354a460a"/>
   </p:sldMasterIdLst>
   <p:notesMasterIdLst>
-    <p:notesMasterId xmlns:r="http://schemas.openxmlformats.org/officeDocument/2006/relationships" r:id="Ra2fc5978019243bd"/>
+    <p:notesMasterId xmlns:r="http://schemas.openxmlformats.org/officeDocument/2006/relationships" r:id="R35bf45c1ebd9486e"/>
   </p:notesMasterIdLst>
   <p:sldIdLst>
-    <p:sldId xmlns:r="http://schemas.openxmlformats.org/officeDocument/2006/relationships" id="256" r:id="R2a16dbbf5878447d"/>
-    <p:sldId xmlns:r="http://schemas.openxmlformats.org/officeDocument/2006/relationships" id="257" r:id="R52b11e30c9514f03"/>
-    <p:sldId xmlns:r="http://schemas.openxmlformats.org/officeDocument/2006/relationships" id="258" r:id="Re06ed8f034504a18"/>
-    <p:sldId xmlns:r="http://schemas.openxmlformats.org/officeDocument/2006/relationships" id="259" r:id="R96e001a3beee4c0e"/>
-    <p:sldId xmlns:r="http://schemas.openxmlformats.org/officeDocument/2006/relationships" id="260" r:id="R0adb08f5d4fe4deb"/>
-    <p:sldId xmlns:r="http://schemas.openxmlformats.org/officeDocument/2006/relationships" id="261" r:id="Rddab83cd1b2d46e6"/>
-    <p:sldId xmlns:r="http://schemas.openxmlformats.org/officeDocument/2006/relationships" id="262" r:id="Rb22a78f104e6468a"/>
-    <p:sldId xmlns:r="http://schemas.openxmlformats.org/officeDocument/2006/relationships" id="263" r:id="R3a6be86ccf784fde"/>
+    <p:sldId xmlns:r="http://schemas.openxmlformats.org/officeDocument/2006/relationships" id="256" r:id="Rf43c8802dfc64852"/>
+    <p:sldId xmlns:r="http://schemas.openxmlformats.org/officeDocument/2006/relationships" id="257" r:id="R0835e25db400411c"/>
+    <p:sldId xmlns:r="http://schemas.openxmlformats.org/officeDocument/2006/relationships" id="258" r:id="Ref3247ef725c4357"/>
+    <p:sldId xmlns:r="http://schemas.openxmlformats.org/officeDocument/2006/relationships" id="259" r:id="R19eb7023870e4035"/>
+    <p:sldId xmlns:r="http://schemas.openxmlformats.org/officeDocument/2006/relationships" id="260" r:id="R01dfbc53f9f045c2"/>
+    <p:sldId xmlns:r="http://schemas.openxmlformats.org/officeDocument/2006/relationships" id="261" r:id="R2191346c559d49de"/>
+    <p:sldId xmlns:r="http://schemas.openxmlformats.org/officeDocument/2006/relationships" id="262" r:id="R52072ccbd8704c7b"/>
+    <p:sldId xmlns:r="http://schemas.openxmlformats.org/officeDocument/2006/relationships" id="263" r:id="Raa327aac845c4574"/>
   </p:sldIdLst>
   <p:sldSz cx="12192000" cy="6858000"/>
   <p:notesSz cx="6858000" cy="9144000"/>
@@ -1069,7 +1069,7 @@
           <a:lstStyle xmlns:a="http://schemas.openxmlformats.org/drawingml/2006/main"/>
           <a:p xmlns:a="http://schemas.openxmlformats.org/drawingml/2006/main">
             <a:r>
-              <a:t>Python/FastAPI, React/TypeScript, PostgreSQL, Exasol Personal/PyExasol and Podman. Upstream products retain their own terms. Fresh-machine reproduction remains unverified. The project requires no paid API or live merchant credentials. The demo recording URL is pending in README.md.</a:t>
+              <a:t>Python/FastAPI, React/TypeScript, PostgreSQL, Exasol Personal/PyExasol and Podman. Upstream products retain their own terms. Fresh-machine reproduction remains unverified. The project requires no paid API or live merchant credentials. The demonstration video and transcript are linked in README.md.</a:t>
             </a:r>
           </a:p>
           <a:p xmlns:a="http://schemas.openxmlformats.org/drawingml/2006/main">
@@ -1141,7 +1141,7 @@
           <p:cNvPr id="3" name="Title">
             <a:extLst xmlns:a="http://schemas.openxmlformats.org/drawingml/2006/main">
               <a:ext uri="{FF2B5EF4-FFF2-40B4-BE49-F238E27FC236}">
-                <a16:creationId xmlns:a16="http://schemas.microsoft.com/office/drawing/2014/main" id="{C7E50A8C-A6B2-48D6-B34A-32F66879204B}"/>
+                <a16:creationId xmlns:a16="http://schemas.microsoft.com/office/drawing/2014/main" id="{5AB9F3F2-B9DE-4592-BCAD-860432F6D0BE}"/>
               </a:ext>
             </a:extLst>
           </p:cNvPr>
@@ -1370,7 +1370,7 @@
           <p:cNvPr id="2" name="Subtitle">
             <a:extLst xmlns:a="http://schemas.openxmlformats.org/drawingml/2006/main">
               <a:ext uri="{FF2B5EF4-FFF2-40B4-BE49-F238E27FC236}">
-                <a16:creationId xmlns:a16="http://schemas.microsoft.com/office/drawing/2014/main" id="{57442565-8713-4ACB-ACE5-88A0FD6D185B}"/>
+                <a16:creationId xmlns:a16="http://schemas.microsoft.com/office/drawing/2014/main" id="{7CCD84E3-E98B-4FA2-8225-D58AA192E148}"/>
               </a:ext>
             </a:extLst>
           </p:cNvPr>
@@ -1616,7 +1616,7 @@
           <p:cNvPr id="2" name="Section title">
             <a:extLst xmlns:a="http://schemas.openxmlformats.org/drawingml/2006/main">
               <a:ext uri="{FF2B5EF4-FFF2-40B4-BE49-F238E27FC236}">
-                <a16:creationId xmlns:a16="http://schemas.microsoft.com/office/drawing/2014/main" id="{1D2D0169-B1FF-4C74-B087-A9548736FF50}"/>
+                <a16:creationId xmlns:a16="http://schemas.microsoft.com/office/drawing/2014/main" id="{90625E86-7514-4711-8614-4CD2D503A04D}"/>
               </a:ext>
             </a:extLst>
           </p:cNvPr>
@@ -1862,7 +1862,7 @@
           <p:cNvPr id="3" name="Title">
             <a:extLst xmlns:a="http://schemas.openxmlformats.org/drawingml/2006/main">
               <a:ext uri="{FF2B5EF4-FFF2-40B4-BE49-F238E27FC236}">
-                <a16:creationId xmlns:a16="http://schemas.microsoft.com/office/drawing/2014/main" id="{C5C7271A-21F4-4FEF-AFAB-C9EC4B7978C7}"/>
+                <a16:creationId xmlns:a16="http://schemas.microsoft.com/office/drawing/2014/main" id="{217C324B-325A-493A-B113-4153919AA6CD}"/>
               </a:ext>
             </a:extLst>
           </p:cNvPr>
@@ -2091,7 +2091,7 @@
           <p:cNvPr id="2" name="Body">
             <a:extLst xmlns:a="http://schemas.openxmlformats.org/drawingml/2006/main">
               <a:ext uri="{FF2B5EF4-FFF2-40B4-BE49-F238E27FC236}">
-                <a16:creationId xmlns:a16="http://schemas.microsoft.com/office/drawing/2014/main" id="{1E76371B-3F60-479D-9B78-306FC3FC569F}"/>
+                <a16:creationId xmlns:a16="http://schemas.microsoft.com/office/drawing/2014/main" id="{DEEE6AE0-F4A9-4F33-AE50-8EB62A0A87DC}"/>
               </a:ext>
             </a:extLst>
           </p:cNvPr>
@@ -2337,7 +2337,7 @@
           <p:cNvPr id="4" name="Title">
             <a:extLst xmlns:a="http://schemas.openxmlformats.org/drawingml/2006/main">
               <a:ext uri="{FF2B5EF4-FFF2-40B4-BE49-F238E27FC236}">
-                <a16:creationId xmlns:a16="http://schemas.microsoft.com/office/drawing/2014/main" id="{97E52B90-5CB7-4D8D-B036-2BB2C13678EB}"/>
+                <a16:creationId xmlns:a16="http://schemas.microsoft.com/office/drawing/2014/main" id="{7182342B-ECEC-4742-B6A0-12B73241A2D4}"/>
               </a:ext>
             </a:extLst>
           </p:cNvPr>
@@ -2566,7 +2566,7 @@
           <p:cNvPr id="2" name="Left column">
             <a:extLst xmlns:a="http://schemas.openxmlformats.org/drawingml/2006/main">
               <a:ext uri="{FF2B5EF4-FFF2-40B4-BE49-F238E27FC236}">
-                <a16:creationId xmlns:a16="http://schemas.microsoft.com/office/drawing/2014/main" id="{66469C24-0CC0-4B9A-82EA-3632D600D434}"/>
+                <a16:creationId xmlns:a16="http://schemas.microsoft.com/office/drawing/2014/main" id="{0E33F6BF-4DFE-48B2-9764-C4B52CFA5578}"/>
               </a:ext>
             </a:extLst>
           </p:cNvPr>
@@ -2795,7 +2795,7 @@
           <p:cNvPr id="3" name="Right column">
             <a:extLst xmlns:a="http://schemas.openxmlformats.org/drawingml/2006/main">
               <a:ext uri="{FF2B5EF4-FFF2-40B4-BE49-F238E27FC236}">
-                <a16:creationId xmlns:a16="http://schemas.microsoft.com/office/drawing/2014/main" id="{295F252F-F1AB-46A4-A282-CCC11D48EF4F}"/>
+                <a16:creationId xmlns:a16="http://schemas.microsoft.com/office/drawing/2014/main" id="{700E9E1C-A800-48FC-B7E6-B97EED8E5E7B}"/>
               </a:ext>
             </a:extLst>
           </p:cNvPr>
@@ -3041,7 +3041,7 @@
           <p:cNvPr id="3" name="Title">
             <a:extLst xmlns:a="http://schemas.openxmlformats.org/drawingml/2006/main">
               <a:ext uri="{FF2B5EF4-FFF2-40B4-BE49-F238E27FC236}">
-                <a16:creationId xmlns:a16="http://schemas.microsoft.com/office/drawing/2014/main" id="{78CD660F-9310-48DB-9A67-9970A449E6C7}"/>
+                <a16:creationId xmlns:a16="http://schemas.microsoft.com/office/drawing/2014/main" id="{07D6159B-E88E-40CA-9E49-7036870F9287}"/>
               </a:ext>
             </a:extLst>
           </p:cNvPr>
@@ -3270,7 +3270,7 @@
           <p:cNvPr id="2" name="Left column">
             <a:extLst xmlns:a="http://schemas.openxmlformats.org/drawingml/2006/main">
               <a:ext uri="{FF2B5EF4-FFF2-40B4-BE49-F238E27FC236}">
-                <a16:creationId xmlns:a16="http://schemas.microsoft.com/office/drawing/2014/main" id="{FC39516C-D2FC-4A32-84B6-914D6252B2B7}"/>
+                <a16:creationId xmlns:a16="http://schemas.microsoft.com/office/drawing/2014/main" id="{781AF251-12FA-4CC3-8963-6832BFA3EF17}"/>
               </a:ext>
             </a:extLst>
           </p:cNvPr>
@@ -3537,12 +3537,12 @@
   </p:cSld>
   <p:clrMap bg1="lt1" tx1="dk1" bg2="lt2" tx2="dk2" accent1="accent1" accent2="accent2" accent3="accent3" accent4="accent4" accent5="accent5" accent6="accent6" hlink="hlink" folHlink="folHlink"/>
   <p:sldLayoutIdLst>
-    <p:sldLayoutId xmlns:r="http://schemas.openxmlformats.org/officeDocument/2006/relationships" id="2147483649" r:id="Rc5b46b69e76645b8"/>
-    <p:sldLayoutId xmlns:r="http://schemas.openxmlformats.org/officeDocument/2006/relationships" id="2147483650" r:id="R0e5a79d670ab48a3"/>
-    <p:sldLayoutId xmlns:r="http://schemas.openxmlformats.org/officeDocument/2006/relationships" id="2147483651" r:id="R4ec3f73dff6a49bd"/>
-    <p:sldLayoutId xmlns:r="http://schemas.openxmlformats.org/officeDocument/2006/relationships" id="2147483652" r:id="R2942f10384464d57"/>
-    <p:sldLayoutId xmlns:r="http://schemas.openxmlformats.org/officeDocument/2006/relationships" id="2147483653" r:id="R2e0fa96c106448a5"/>
-    <p:sldLayoutId xmlns:r="http://schemas.openxmlformats.org/officeDocument/2006/relationships" id="2147483654" r:id="R39cb7b8e137144c7"/>
+    <p:sldLayoutId xmlns:r="http://schemas.openxmlformats.org/officeDocument/2006/relationships" id="2147483649" r:id="R1b9057bc168043e9"/>
+    <p:sldLayoutId xmlns:r="http://schemas.openxmlformats.org/officeDocument/2006/relationships" id="2147483650" r:id="R3c14b3db507c44ae"/>
+    <p:sldLayoutId xmlns:r="http://schemas.openxmlformats.org/officeDocument/2006/relationships" id="2147483651" r:id="Ree7a42cab1374d4c"/>
+    <p:sldLayoutId xmlns:r="http://schemas.openxmlformats.org/officeDocument/2006/relationships" id="2147483652" r:id="R33f2745ace5040ac"/>
+    <p:sldLayoutId xmlns:r="http://schemas.openxmlformats.org/officeDocument/2006/relationships" id="2147483653" r:id="R21d3e5c4ec5f4ecc"/>
+    <p:sldLayoutId xmlns:r="http://schemas.openxmlformats.org/officeDocument/2006/relationships" id="2147483654" r:id="R7fe38adb3f1e43d2"/>
   </p:sldLayoutIdLst>
   <p:txStyles>
     <p:titleStyle>
@@ -4093,7 +4093,7 @@
           <p:cNvPr id="4" name="">
             <a:extLst xmlns:a="http://schemas.openxmlformats.org/drawingml/2006/main">
               <a:ext uri="{FF2B5EF4-FFF2-40B4-BE49-F238E27FC236}">
-                <a16:creationId xmlns:a16="http://schemas.microsoft.com/office/drawing/2014/main" id="{172384D4-7A71-4DCC-AF1F-D3DAE45D9DC5}"/>
+                <a16:creationId xmlns:a16="http://schemas.microsoft.com/office/drawing/2014/main" id="{C429F7D2-8504-42A8-A56C-9C60F383AE11}"/>
               </a:ext>
             </a:extLst>
           </p:cNvPr>
@@ -4249,7 +4249,7 @@
           <p:cNvPr id="2" name="">
             <a:extLst xmlns:a="http://schemas.openxmlformats.org/drawingml/2006/main">
               <a:ext uri="{FF2B5EF4-FFF2-40B4-BE49-F238E27FC236}">
-                <a16:creationId xmlns:a16="http://schemas.microsoft.com/office/drawing/2014/main" id="{6662A620-8CC2-4F74-801A-44BAC9184C57}"/>
+                <a16:creationId xmlns:a16="http://schemas.microsoft.com/office/drawing/2014/main" id="{E970AA43-E156-44A0-BA19-B2519A22CBA9}"/>
               </a:ext>
             </a:extLst>
           </p:cNvPr>
@@ -4428,7 +4428,7 @@
           <p:cNvPr id="3" name="">
             <a:extLst xmlns:a="http://schemas.openxmlformats.org/drawingml/2006/main">
               <a:ext uri="{FF2B5EF4-FFF2-40B4-BE49-F238E27FC236}">
-                <a16:creationId xmlns:a16="http://schemas.microsoft.com/office/drawing/2014/main" id="{185409A3-A0BF-4D00-BC3A-B36B2DA06E36}"/>
+                <a16:creationId xmlns:a16="http://schemas.microsoft.com/office/drawing/2014/main" id="{F4F33253-5864-430C-BC1C-8F10957C735F}"/>
               </a:ext>
             </a:extLst>
           </p:cNvPr>
@@ -4582,7 +4582,7 @@
     </p:spTree>
     <p:extLst>
       <p:ext uri="{BB962C8B-B14F-4D97-AF65-F5344CB8AC3E}">
-        <p14:creationId xmlns:p14="http://schemas.microsoft.com/office/powerpoint/2010/main" val="341128224"/>
+        <p14:creationId xmlns:p14="http://schemas.microsoft.com/office/powerpoint/2010/main" val="428488073"/>
       </p:ext>
     </p:extLst>
   </p:cSld>
@@ -4613,7 +4613,7 @@
           <p:cNvPr id="10" name="">
             <a:extLst xmlns:a="http://schemas.openxmlformats.org/drawingml/2006/main">
               <a:ext uri="{FF2B5EF4-FFF2-40B4-BE49-F238E27FC236}">
-                <a16:creationId xmlns:a16="http://schemas.microsoft.com/office/drawing/2014/main" id="{4EA384B2-B9AC-48B5-8850-8E4F1B224636}"/>
+                <a16:creationId xmlns:a16="http://schemas.microsoft.com/office/drawing/2014/main" id="{507F079C-135F-4B16-A54A-DBAD15DD47F4}"/>
               </a:ext>
             </a:extLst>
           </p:cNvPr>
@@ -4769,7 +4769,7 @@
           <p:cNvPr id="2" name="">
             <a:extLst xmlns:a="http://schemas.openxmlformats.org/drawingml/2006/main">
               <a:ext uri="{FF2B5EF4-FFF2-40B4-BE49-F238E27FC236}">
-                <a16:creationId xmlns:a16="http://schemas.microsoft.com/office/drawing/2014/main" id="{CC5F9C50-EB89-41E6-AC68-44F5603B3BF5}"/>
+                <a16:creationId xmlns:a16="http://schemas.microsoft.com/office/drawing/2014/main" id="{DF1C0607-8914-41EB-AAE8-3FF4087DD65B}"/>
               </a:ext>
             </a:extLst>
           </p:cNvPr>
@@ -4925,7 +4925,7 @@
           <p:cNvPr id="3" name="">
             <a:extLst xmlns:a="http://schemas.openxmlformats.org/drawingml/2006/main">
               <a:ext uri="{FF2B5EF4-FFF2-40B4-BE49-F238E27FC236}">
-                <a16:creationId xmlns:a16="http://schemas.microsoft.com/office/drawing/2014/main" id="{AAE9EBE0-99AD-48F3-A906-CBFFC1209D24}"/>
+                <a16:creationId xmlns:a16="http://schemas.microsoft.com/office/drawing/2014/main" id="{B9C9FB30-949B-4740-9C77-4E7E6EF73435}"/>
               </a:ext>
             </a:extLst>
           </p:cNvPr>
@@ -5081,7 +5081,7 @@
           <p:cNvPr id="4" name="">
             <a:extLst xmlns:a="http://schemas.openxmlformats.org/drawingml/2006/main">
               <a:ext uri="{FF2B5EF4-FFF2-40B4-BE49-F238E27FC236}">
-                <a16:creationId xmlns:a16="http://schemas.microsoft.com/office/drawing/2014/main" id="{8F937309-92CA-4FA8-8286-CC79F6DC929F}"/>
+                <a16:creationId xmlns:a16="http://schemas.microsoft.com/office/drawing/2014/main" id="{1C4074AA-760D-4494-8E78-E8D739229186}"/>
               </a:ext>
             </a:extLst>
           </p:cNvPr>
@@ -5237,7 +5237,7 @@
           <p:cNvPr id="5" name="">
             <a:extLst xmlns:a="http://schemas.openxmlformats.org/drawingml/2006/main">
               <a:ext uri="{FF2B5EF4-FFF2-40B4-BE49-F238E27FC236}">
-                <a16:creationId xmlns:a16="http://schemas.microsoft.com/office/drawing/2014/main" id="{D5788941-26AC-4E23-A148-6F6BC3626365}"/>
+                <a16:creationId xmlns:a16="http://schemas.microsoft.com/office/drawing/2014/main" id="{6288C312-3498-445B-81D6-EEA43819E653}"/>
               </a:ext>
             </a:extLst>
           </p:cNvPr>
@@ -5393,7 +5393,7 @@
           <p:cNvPr id="6" name="">
             <a:extLst xmlns:a="http://schemas.openxmlformats.org/drawingml/2006/main">
               <a:ext uri="{FF2B5EF4-FFF2-40B4-BE49-F238E27FC236}">
-                <a16:creationId xmlns:a16="http://schemas.microsoft.com/office/drawing/2014/main" id="{BD4857FF-54EA-4522-AA83-CB9F09069DB3}"/>
+                <a16:creationId xmlns:a16="http://schemas.microsoft.com/office/drawing/2014/main" id="{14DAE5DF-F3F2-4207-8D2B-5DA3ABDB8BE0}"/>
               </a:ext>
             </a:extLst>
           </p:cNvPr>
@@ -5549,7 +5549,7 @@
           <p:cNvPr id="7" name="">
             <a:extLst xmlns:a="http://schemas.openxmlformats.org/drawingml/2006/main">
               <a:ext uri="{FF2B5EF4-FFF2-40B4-BE49-F238E27FC236}">
-                <a16:creationId xmlns:a16="http://schemas.microsoft.com/office/drawing/2014/main" id="{4916FB81-45EB-49A4-A8BC-FC72074E6677}"/>
+                <a16:creationId xmlns:a16="http://schemas.microsoft.com/office/drawing/2014/main" id="{E0002BA4-4466-402D-98A1-36DF01207B87}"/>
               </a:ext>
             </a:extLst>
           </p:cNvPr>
@@ -5705,7 +5705,7 @@
           <p:cNvPr id="8" name="">
             <a:extLst xmlns:a="http://schemas.openxmlformats.org/drawingml/2006/main">
               <a:ext uri="{FF2B5EF4-FFF2-40B4-BE49-F238E27FC236}">
-                <a16:creationId xmlns:a16="http://schemas.microsoft.com/office/drawing/2014/main" id="{2C05F14E-3B02-41DD-A821-C8070592378E}"/>
+                <a16:creationId xmlns:a16="http://schemas.microsoft.com/office/drawing/2014/main" id="{821EB1E6-EB63-4652-96CC-D2129E47A280}"/>
               </a:ext>
             </a:extLst>
           </p:cNvPr>
@@ -5861,7 +5861,7 @@
           <p:cNvPr id="9" name="">
             <a:extLst xmlns:a="http://schemas.openxmlformats.org/drawingml/2006/main">
               <a:ext uri="{FF2B5EF4-FFF2-40B4-BE49-F238E27FC236}">
-                <a16:creationId xmlns:a16="http://schemas.microsoft.com/office/drawing/2014/main" id="{B9721BEA-080B-41D8-8726-9E2C8A145DB6}"/>
+                <a16:creationId xmlns:a16="http://schemas.microsoft.com/office/drawing/2014/main" id="{0305FFEE-0228-4958-B2C1-801F2D3D87DD}"/>
               </a:ext>
             </a:extLst>
           </p:cNvPr>
@@ -6015,7 +6015,7 @@
     </p:spTree>
     <p:extLst>
       <p:ext uri="{BB962C8B-B14F-4D97-AF65-F5344CB8AC3E}">
-        <p14:creationId xmlns:p14="http://schemas.microsoft.com/office/powerpoint/2010/main" val="2084797814"/>
+        <p14:creationId xmlns:p14="http://schemas.microsoft.com/office/powerpoint/2010/main" val="768677883"/>
       </p:ext>
     </p:extLst>
   </p:cSld>
@@ -6046,7 +6046,7 @@
           <p:cNvPr id="10" name="">
             <a:extLst xmlns:a="http://schemas.openxmlformats.org/drawingml/2006/main">
               <a:ext uri="{FF2B5EF4-FFF2-40B4-BE49-F238E27FC236}">
-                <a16:creationId xmlns:a16="http://schemas.microsoft.com/office/drawing/2014/main" id="{5E7CF310-F11C-4705-BB5A-11492F2482EA}"/>
+                <a16:creationId xmlns:a16="http://schemas.microsoft.com/office/drawing/2014/main" id="{25A5E5D4-C5DB-4917-AA8E-0BB1D9CBB0A2}"/>
               </a:ext>
             </a:extLst>
           </p:cNvPr>
@@ -6202,7 +6202,7 @@
           <p:cNvPr id="2" name="">
             <a:extLst xmlns:a="http://schemas.openxmlformats.org/drawingml/2006/main">
               <a:ext uri="{FF2B5EF4-FFF2-40B4-BE49-F238E27FC236}">
-                <a16:creationId xmlns:a16="http://schemas.microsoft.com/office/drawing/2014/main" id="{54D3042E-4D80-4DC5-8CF5-C3F6B9388486}"/>
+                <a16:creationId xmlns:a16="http://schemas.microsoft.com/office/drawing/2014/main" id="{4B6B134C-AA55-4103-9FE4-49C58BEEAF40}"/>
               </a:ext>
             </a:extLst>
           </p:cNvPr>
@@ -6358,7 +6358,7 @@
           <p:cNvPr id="3" name="">
             <a:extLst xmlns:a="http://schemas.openxmlformats.org/drawingml/2006/main">
               <a:ext uri="{FF2B5EF4-FFF2-40B4-BE49-F238E27FC236}">
-                <a16:creationId xmlns:a16="http://schemas.microsoft.com/office/drawing/2014/main" id="{86FDAE99-31FB-4B5D-97CE-4966C80F7A80}"/>
+                <a16:creationId xmlns:a16="http://schemas.microsoft.com/office/drawing/2014/main" id="{31DFC756-FB9B-442A-A68F-5F28803DFAD0}"/>
               </a:ext>
             </a:extLst>
           </p:cNvPr>
@@ -6514,7 +6514,7 @@
           <p:cNvPr id="4" name="">
             <a:extLst xmlns:a="http://schemas.openxmlformats.org/drawingml/2006/main">
               <a:ext uri="{FF2B5EF4-FFF2-40B4-BE49-F238E27FC236}">
-                <a16:creationId xmlns:a16="http://schemas.microsoft.com/office/drawing/2014/main" id="{D80ECA98-D325-4A68-9892-180485E9EC59}"/>
+                <a16:creationId xmlns:a16="http://schemas.microsoft.com/office/drawing/2014/main" id="{0CB235F7-B0AA-4383-B53E-360221C04DF6}"/>
               </a:ext>
             </a:extLst>
           </p:cNvPr>
@@ -6670,7 +6670,7 @@
           <p:cNvPr id="5" name="">
             <a:extLst xmlns:a="http://schemas.openxmlformats.org/drawingml/2006/main">
               <a:ext uri="{FF2B5EF4-FFF2-40B4-BE49-F238E27FC236}">
-                <a16:creationId xmlns:a16="http://schemas.microsoft.com/office/drawing/2014/main" id="{339340F3-F6C4-4ACA-9F9A-4BB89EB43D69}"/>
+                <a16:creationId xmlns:a16="http://schemas.microsoft.com/office/drawing/2014/main" id="{1BF28823-5390-4EF5-A976-C97DFE75111F}"/>
               </a:ext>
             </a:extLst>
           </p:cNvPr>
@@ -6826,7 +6826,7 @@
           <p:cNvPr id="6" name="">
             <a:extLst xmlns:a="http://schemas.openxmlformats.org/drawingml/2006/main">
               <a:ext uri="{FF2B5EF4-FFF2-40B4-BE49-F238E27FC236}">
-                <a16:creationId xmlns:a16="http://schemas.microsoft.com/office/drawing/2014/main" id="{F0294202-69C1-48F7-B1DF-DD7F06348AD9}"/>
+                <a16:creationId xmlns:a16="http://schemas.microsoft.com/office/drawing/2014/main" id="{EDE80EA1-6768-4E3D-BFCC-E364F912E873}"/>
               </a:ext>
             </a:extLst>
           </p:cNvPr>
@@ -6982,7 +6982,7 @@
           <p:cNvPr id="7" name="">
             <a:extLst xmlns:a="http://schemas.openxmlformats.org/drawingml/2006/main">
               <a:ext uri="{FF2B5EF4-FFF2-40B4-BE49-F238E27FC236}">
-                <a16:creationId xmlns:a16="http://schemas.microsoft.com/office/drawing/2014/main" id="{278ACB1E-CBA9-4E7A-948A-B985B3867C78}"/>
+                <a16:creationId xmlns:a16="http://schemas.microsoft.com/office/drawing/2014/main" id="{B553277D-3477-43F3-9E3D-4F3269498746}"/>
               </a:ext>
             </a:extLst>
           </p:cNvPr>
@@ -7138,7 +7138,7 @@
           <p:cNvPr id="8" name="">
             <a:extLst xmlns:a="http://schemas.openxmlformats.org/drawingml/2006/main">
               <a:ext uri="{FF2B5EF4-FFF2-40B4-BE49-F238E27FC236}">
-                <a16:creationId xmlns:a16="http://schemas.microsoft.com/office/drawing/2014/main" id="{F8858408-817D-4517-A44F-28CF79A93C48}"/>
+                <a16:creationId xmlns:a16="http://schemas.microsoft.com/office/drawing/2014/main" id="{876442A1-2575-421A-B05C-92F173A7E972}"/>
               </a:ext>
             </a:extLst>
           </p:cNvPr>
@@ -7294,7 +7294,7 @@
           <p:cNvPr id="9" name="">
             <a:extLst xmlns:a="http://schemas.openxmlformats.org/drawingml/2006/main">
               <a:ext uri="{FF2B5EF4-FFF2-40B4-BE49-F238E27FC236}">
-                <a16:creationId xmlns:a16="http://schemas.microsoft.com/office/drawing/2014/main" id="{5A134DDB-55C0-45A7-8212-3AFA174F62DD}"/>
+                <a16:creationId xmlns:a16="http://schemas.microsoft.com/office/drawing/2014/main" id="{DFD0CD7F-F27B-4277-8021-A1725480F044}"/>
               </a:ext>
             </a:extLst>
           </p:cNvPr>
@@ -7448,7 +7448,7 @@
     </p:spTree>
     <p:extLst>
       <p:ext uri="{BB962C8B-B14F-4D97-AF65-F5344CB8AC3E}">
-        <p14:creationId xmlns:p14="http://schemas.microsoft.com/office/powerpoint/2010/main" val="1039445931"/>
+        <p14:creationId xmlns:p14="http://schemas.microsoft.com/office/powerpoint/2010/main" val="865218575"/>
       </p:ext>
     </p:extLst>
   </p:cSld>
@@ -7479,7 +7479,7 @@
           <p:cNvPr id="10" name="">
             <a:extLst xmlns:a="http://schemas.openxmlformats.org/drawingml/2006/main">
               <a:ext uri="{FF2B5EF4-FFF2-40B4-BE49-F238E27FC236}">
-                <a16:creationId xmlns:a16="http://schemas.microsoft.com/office/drawing/2014/main" id="{199A76A5-4E8C-4254-9129-E3B40130956C}"/>
+                <a16:creationId xmlns:a16="http://schemas.microsoft.com/office/drawing/2014/main" id="{83B7E760-8D4B-4E03-9B62-FB9B3FFF7AA7}"/>
               </a:ext>
             </a:extLst>
           </p:cNvPr>
@@ -7635,7 +7635,7 @@
           <p:cNvPr id="2" name="">
             <a:extLst xmlns:a="http://schemas.openxmlformats.org/drawingml/2006/main">
               <a:ext uri="{FF2B5EF4-FFF2-40B4-BE49-F238E27FC236}">
-                <a16:creationId xmlns:a16="http://schemas.microsoft.com/office/drawing/2014/main" id="{0A39E24D-FD6A-420C-9227-067B439ABC70}"/>
+                <a16:creationId xmlns:a16="http://schemas.microsoft.com/office/drawing/2014/main" id="{7EFFABC1-7726-43F4-93BB-AD965439B827}"/>
               </a:ext>
             </a:extLst>
           </p:cNvPr>
@@ -7791,7 +7791,7 @@
           <p:cNvPr id="3" name="">
             <a:extLst xmlns:a="http://schemas.openxmlformats.org/drawingml/2006/main">
               <a:ext uri="{FF2B5EF4-FFF2-40B4-BE49-F238E27FC236}">
-                <a16:creationId xmlns:a16="http://schemas.microsoft.com/office/drawing/2014/main" id="{13DE3321-10D9-4027-96A6-4ED6EC415A72}"/>
+                <a16:creationId xmlns:a16="http://schemas.microsoft.com/office/drawing/2014/main" id="{AD987D9C-F976-430F-91C0-8FFE36516A1E}"/>
               </a:ext>
             </a:extLst>
           </p:cNvPr>
@@ -7947,7 +7947,7 @@
           <p:cNvPr id="4" name="">
             <a:extLst xmlns:a="http://schemas.openxmlformats.org/drawingml/2006/main">
               <a:ext uri="{FF2B5EF4-FFF2-40B4-BE49-F238E27FC236}">
-                <a16:creationId xmlns:a16="http://schemas.microsoft.com/office/drawing/2014/main" id="{B4E94D84-B50D-4B94-8FE4-639D2323FCEA}"/>
+                <a16:creationId xmlns:a16="http://schemas.microsoft.com/office/drawing/2014/main" id="{2B27172D-F8E2-45EC-9AED-A3F7D1006A1E}"/>
               </a:ext>
             </a:extLst>
           </p:cNvPr>
@@ -8103,7 +8103,7 @@
           <p:cNvPr id="5" name="">
             <a:extLst xmlns:a="http://schemas.openxmlformats.org/drawingml/2006/main">
               <a:ext uri="{FF2B5EF4-FFF2-40B4-BE49-F238E27FC236}">
-                <a16:creationId xmlns:a16="http://schemas.microsoft.com/office/drawing/2014/main" id="{AB8B4614-A012-4294-8CAC-10A7EC1C5E3E}"/>
+                <a16:creationId xmlns:a16="http://schemas.microsoft.com/office/drawing/2014/main" id="{7A19EFC3-08A8-4BEF-A248-F9CE033C69AB}"/>
               </a:ext>
             </a:extLst>
           </p:cNvPr>
@@ -8259,7 +8259,7 @@
           <p:cNvPr id="6" name="">
             <a:extLst xmlns:a="http://schemas.openxmlformats.org/drawingml/2006/main">
               <a:ext uri="{FF2B5EF4-FFF2-40B4-BE49-F238E27FC236}">
-                <a16:creationId xmlns:a16="http://schemas.microsoft.com/office/drawing/2014/main" id="{072C458A-A8C5-45EF-AF55-D5A5BDB65A07}"/>
+                <a16:creationId xmlns:a16="http://schemas.microsoft.com/office/drawing/2014/main" id="{B963B615-85BF-49D4-898A-E0A8AB91D9C0}"/>
               </a:ext>
             </a:extLst>
           </p:cNvPr>
@@ -8415,7 +8415,7 @@
           <p:cNvPr id="7" name="">
             <a:extLst xmlns:a="http://schemas.openxmlformats.org/drawingml/2006/main">
               <a:ext uri="{FF2B5EF4-FFF2-40B4-BE49-F238E27FC236}">
-                <a16:creationId xmlns:a16="http://schemas.microsoft.com/office/drawing/2014/main" id="{D62F110A-EDEC-43EF-903D-8C749F4594E5}"/>
+                <a16:creationId xmlns:a16="http://schemas.microsoft.com/office/drawing/2014/main" id="{C024C64C-41A1-4D84-9A1E-B89D96E9888E}"/>
               </a:ext>
             </a:extLst>
           </p:cNvPr>
@@ -8571,7 +8571,7 @@
           <p:cNvPr id="8" name="">
             <a:extLst xmlns:a="http://schemas.openxmlformats.org/drawingml/2006/main">
               <a:ext uri="{FF2B5EF4-FFF2-40B4-BE49-F238E27FC236}">
-                <a16:creationId xmlns:a16="http://schemas.microsoft.com/office/drawing/2014/main" id="{7D4440FA-642A-487E-BC06-B7598932848F}"/>
+                <a16:creationId xmlns:a16="http://schemas.microsoft.com/office/drawing/2014/main" id="{16E13ADE-7310-4249-9AE4-5AEF43063576}"/>
               </a:ext>
             </a:extLst>
           </p:cNvPr>
@@ -8727,7 +8727,7 @@
           <p:cNvPr id="9" name="">
             <a:extLst xmlns:a="http://schemas.openxmlformats.org/drawingml/2006/main">
               <a:ext uri="{FF2B5EF4-FFF2-40B4-BE49-F238E27FC236}">
-                <a16:creationId xmlns:a16="http://schemas.microsoft.com/office/drawing/2014/main" id="{E974AD2A-509B-4F27-B274-B5432FB6AD83}"/>
+                <a16:creationId xmlns:a16="http://schemas.microsoft.com/office/drawing/2014/main" id="{48DC020F-7AB7-49FF-92A4-7959CA96F423}"/>
               </a:ext>
             </a:extLst>
           </p:cNvPr>
@@ -8881,7 +8881,7 @@
     </p:spTree>
     <p:extLst>
       <p:ext uri="{BB962C8B-B14F-4D97-AF65-F5344CB8AC3E}">
-        <p14:creationId xmlns:p14="http://schemas.microsoft.com/office/powerpoint/2010/main" val="1097101057"/>
+        <p14:creationId xmlns:p14="http://schemas.microsoft.com/office/powerpoint/2010/main" val="232884519"/>
       </p:ext>
     </p:extLst>
   </p:cSld>
@@ -8912,7 +8912,7 @@
           <p:cNvPr id="10" name="">
             <a:extLst xmlns:a="http://schemas.openxmlformats.org/drawingml/2006/main">
               <a:ext uri="{FF2B5EF4-FFF2-40B4-BE49-F238E27FC236}">
-                <a16:creationId xmlns:a16="http://schemas.microsoft.com/office/drawing/2014/main" id="{DDEC8F87-4F4F-45FD-AFB0-0C09BA428C72}"/>
+                <a16:creationId xmlns:a16="http://schemas.microsoft.com/office/drawing/2014/main" id="{4EEB1A7E-8C90-4C99-A90E-797F8D224AA1}"/>
               </a:ext>
             </a:extLst>
           </p:cNvPr>
@@ -9068,7 +9068,7 @@
           <p:cNvPr id="2" name="">
             <a:extLst xmlns:a="http://schemas.openxmlformats.org/drawingml/2006/main">
               <a:ext uri="{FF2B5EF4-FFF2-40B4-BE49-F238E27FC236}">
-                <a16:creationId xmlns:a16="http://schemas.microsoft.com/office/drawing/2014/main" id="{26368C7B-469D-4720-A385-58BBE23EFAE1}"/>
+                <a16:creationId xmlns:a16="http://schemas.microsoft.com/office/drawing/2014/main" id="{A66FC3C5-AC9D-43B7-A873-F23F19210CE5}"/>
               </a:ext>
             </a:extLst>
           </p:cNvPr>
@@ -9224,7 +9224,7 @@
           <p:cNvPr id="3" name="">
             <a:extLst xmlns:a="http://schemas.openxmlformats.org/drawingml/2006/main">
               <a:ext uri="{FF2B5EF4-FFF2-40B4-BE49-F238E27FC236}">
-                <a16:creationId xmlns:a16="http://schemas.microsoft.com/office/drawing/2014/main" id="{862B8022-CEA5-46AD-A520-28AC989562C2}"/>
+                <a16:creationId xmlns:a16="http://schemas.microsoft.com/office/drawing/2014/main" id="{46916FB0-6EE1-4B4F-9B7D-9A27A893392D}"/>
               </a:ext>
             </a:extLst>
           </p:cNvPr>
@@ -9380,7 +9380,7 @@
           <p:cNvPr id="4" name="">
             <a:extLst xmlns:a="http://schemas.openxmlformats.org/drawingml/2006/main">
               <a:ext uri="{FF2B5EF4-FFF2-40B4-BE49-F238E27FC236}">
-                <a16:creationId xmlns:a16="http://schemas.microsoft.com/office/drawing/2014/main" id="{AC536427-1C64-4FD2-B193-0B3B055B537D}"/>
+                <a16:creationId xmlns:a16="http://schemas.microsoft.com/office/drawing/2014/main" id="{4B5A1A1E-F9FA-4AD3-841D-B1E6FC8C8DD3}"/>
               </a:ext>
             </a:extLst>
           </p:cNvPr>
@@ -9536,7 +9536,7 @@
           <p:cNvPr id="5" name="">
             <a:extLst xmlns:a="http://schemas.openxmlformats.org/drawingml/2006/main">
               <a:ext uri="{FF2B5EF4-FFF2-40B4-BE49-F238E27FC236}">
-                <a16:creationId xmlns:a16="http://schemas.microsoft.com/office/drawing/2014/main" id="{A4B5B390-48C5-4634-AFF2-2000218E01F3}"/>
+                <a16:creationId xmlns:a16="http://schemas.microsoft.com/office/drawing/2014/main" id="{0C5C4A40-274B-443A-8D96-D27E3EDC8F29}"/>
               </a:ext>
             </a:extLst>
           </p:cNvPr>
@@ -9692,7 +9692,7 @@
           <p:cNvPr id="6" name="">
             <a:extLst xmlns:a="http://schemas.openxmlformats.org/drawingml/2006/main">
               <a:ext uri="{FF2B5EF4-FFF2-40B4-BE49-F238E27FC236}">
-                <a16:creationId xmlns:a16="http://schemas.microsoft.com/office/drawing/2014/main" id="{1012AC22-97E6-4CF3-B444-8377688FB309}"/>
+                <a16:creationId xmlns:a16="http://schemas.microsoft.com/office/drawing/2014/main" id="{A24BD494-9244-4E37-935C-9A17820B50AB}"/>
               </a:ext>
             </a:extLst>
           </p:cNvPr>
@@ -9848,7 +9848,7 @@
           <p:cNvPr id="7" name="">
             <a:extLst xmlns:a="http://schemas.openxmlformats.org/drawingml/2006/main">
               <a:ext uri="{FF2B5EF4-FFF2-40B4-BE49-F238E27FC236}">
-                <a16:creationId xmlns:a16="http://schemas.microsoft.com/office/drawing/2014/main" id="{B316C7F9-B11F-4D6C-919C-E97F7CAC90D8}"/>
+                <a16:creationId xmlns:a16="http://schemas.microsoft.com/office/drawing/2014/main" id="{1AE79AB8-7A5D-43E2-BE27-0AAFFB6BA773}"/>
               </a:ext>
             </a:extLst>
           </p:cNvPr>
@@ -10004,7 +10004,7 @@
           <p:cNvPr id="8" name="">
             <a:extLst xmlns:a="http://schemas.openxmlformats.org/drawingml/2006/main">
               <a:ext uri="{FF2B5EF4-FFF2-40B4-BE49-F238E27FC236}">
-                <a16:creationId xmlns:a16="http://schemas.microsoft.com/office/drawing/2014/main" id="{653DC35C-8160-417A-8719-F155C0D97200}"/>
+                <a16:creationId xmlns:a16="http://schemas.microsoft.com/office/drawing/2014/main" id="{30BA4F0F-E1F2-49EF-863F-9DCFDE04839B}"/>
               </a:ext>
             </a:extLst>
           </p:cNvPr>
@@ -10160,7 +10160,7 @@
           <p:cNvPr id="9" name="">
             <a:extLst xmlns:a="http://schemas.openxmlformats.org/drawingml/2006/main">
               <a:ext uri="{FF2B5EF4-FFF2-40B4-BE49-F238E27FC236}">
-                <a16:creationId xmlns:a16="http://schemas.microsoft.com/office/drawing/2014/main" id="{CF82B136-A337-4FF0-88ED-4CF88F6B5EB5}"/>
+                <a16:creationId xmlns:a16="http://schemas.microsoft.com/office/drawing/2014/main" id="{BD269A7B-5412-4ECB-970A-21BB0170DE94}"/>
               </a:ext>
             </a:extLst>
           </p:cNvPr>
@@ -10314,7 +10314,7 @@
     </p:spTree>
     <p:extLst>
       <p:ext uri="{BB962C8B-B14F-4D97-AF65-F5344CB8AC3E}">
-        <p14:creationId xmlns:p14="http://schemas.microsoft.com/office/powerpoint/2010/main" val="1295343714"/>
+        <p14:creationId xmlns:p14="http://schemas.microsoft.com/office/powerpoint/2010/main" val="970095118"/>
       </p:ext>
     </p:extLst>
   </p:cSld>
@@ -10345,7 +10345,7 @@
           <p:cNvPr id="10" name="">
             <a:extLst xmlns:a="http://schemas.openxmlformats.org/drawingml/2006/main">
               <a:ext uri="{FF2B5EF4-FFF2-40B4-BE49-F238E27FC236}">
-                <a16:creationId xmlns:a16="http://schemas.microsoft.com/office/drawing/2014/main" id="{4EB9A068-F409-4328-B274-FD3931E3FFB3}"/>
+                <a16:creationId xmlns:a16="http://schemas.microsoft.com/office/drawing/2014/main" id="{C043452E-16F2-4C23-8F79-AE58B2EF91D8}"/>
               </a:ext>
             </a:extLst>
           </p:cNvPr>
@@ -10501,7 +10501,7 @@
           <p:cNvPr id="2" name="">
             <a:extLst xmlns:a="http://schemas.openxmlformats.org/drawingml/2006/main">
               <a:ext uri="{FF2B5EF4-FFF2-40B4-BE49-F238E27FC236}">
-                <a16:creationId xmlns:a16="http://schemas.microsoft.com/office/drawing/2014/main" id="{6E7625F2-77AD-45FE-BAD6-0CF00267DBED}"/>
+                <a16:creationId xmlns:a16="http://schemas.microsoft.com/office/drawing/2014/main" id="{382B8D93-AF5E-470C-BBB7-908CDFD0409D}"/>
               </a:ext>
             </a:extLst>
           </p:cNvPr>
@@ -10657,7 +10657,7 @@
           <p:cNvPr id="3" name="">
             <a:extLst xmlns:a="http://schemas.openxmlformats.org/drawingml/2006/main">
               <a:ext uri="{FF2B5EF4-FFF2-40B4-BE49-F238E27FC236}">
-                <a16:creationId xmlns:a16="http://schemas.microsoft.com/office/drawing/2014/main" id="{1B648873-F0AF-4447-A45F-FAE63499EEC8}"/>
+                <a16:creationId xmlns:a16="http://schemas.microsoft.com/office/drawing/2014/main" id="{F7E05E89-8624-4BC1-950A-20DA70AA3D82}"/>
               </a:ext>
             </a:extLst>
           </p:cNvPr>
@@ -10813,7 +10813,7 @@
           <p:cNvPr id="4" name="">
             <a:extLst xmlns:a="http://schemas.openxmlformats.org/drawingml/2006/main">
               <a:ext uri="{FF2B5EF4-FFF2-40B4-BE49-F238E27FC236}">
-                <a16:creationId xmlns:a16="http://schemas.microsoft.com/office/drawing/2014/main" id="{5B718787-36F8-42BA-A4B9-B5B37B22BD16}"/>
+                <a16:creationId xmlns:a16="http://schemas.microsoft.com/office/drawing/2014/main" id="{87360742-8206-46E8-A060-A946F24044C0}"/>
               </a:ext>
             </a:extLst>
           </p:cNvPr>
@@ -10969,7 +10969,7 @@
           <p:cNvPr id="5" name="">
             <a:extLst xmlns:a="http://schemas.openxmlformats.org/drawingml/2006/main">
               <a:ext uri="{FF2B5EF4-FFF2-40B4-BE49-F238E27FC236}">
-                <a16:creationId xmlns:a16="http://schemas.microsoft.com/office/drawing/2014/main" id="{27177E2F-B1FC-46E9-8281-ACCCF0F3D6BE}"/>
+                <a16:creationId xmlns:a16="http://schemas.microsoft.com/office/drawing/2014/main" id="{D9CB04BE-84A4-41EC-985D-8A68F9CBBFA8}"/>
               </a:ext>
             </a:extLst>
           </p:cNvPr>
@@ -11125,7 +11125,7 @@
           <p:cNvPr id="6" name="">
             <a:extLst xmlns:a="http://schemas.openxmlformats.org/drawingml/2006/main">
               <a:ext uri="{FF2B5EF4-FFF2-40B4-BE49-F238E27FC236}">
-                <a16:creationId xmlns:a16="http://schemas.microsoft.com/office/drawing/2014/main" id="{B79D30D3-7B8D-4637-A3E8-6189F102AAF0}"/>
+                <a16:creationId xmlns:a16="http://schemas.microsoft.com/office/drawing/2014/main" id="{BD1B1E0A-A4BB-4CBF-9E0B-4F4869FFAAA9}"/>
               </a:ext>
             </a:extLst>
           </p:cNvPr>
@@ -11281,7 +11281,7 @@
           <p:cNvPr id="7" name="">
             <a:extLst xmlns:a="http://schemas.openxmlformats.org/drawingml/2006/main">
               <a:ext uri="{FF2B5EF4-FFF2-40B4-BE49-F238E27FC236}">
-                <a16:creationId xmlns:a16="http://schemas.microsoft.com/office/drawing/2014/main" id="{9D2D6685-0F88-444E-8C52-9DF32DC8C922}"/>
+                <a16:creationId xmlns:a16="http://schemas.microsoft.com/office/drawing/2014/main" id="{84F4BE95-2E85-4A9B-A885-3E1F3815AB8D}"/>
               </a:ext>
             </a:extLst>
           </p:cNvPr>
@@ -11437,7 +11437,7 @@
           <p:cNvPr id="8" name="">
             <a:extLst xmlns:a="http://schemas.openxmlformats.org/drawingml/2006/main">
               <a:ext uri="{FF2B5EF4-FFF2-40B4-BE49-F238E27FC236}">
-                <a16:creationId xmlns:a16="http://schemas.microsoft.com/office/drawing/2014/main" id="{38F8CEE8-BCBD-458B-95AE-EDF48BFB2E2B}"/>
+                <a16:creationId xmlns:a16="http://schemas.microsoft.com/office/drawing/2014/main" id="{C0CD96AA-CA14-4BFE-8862-6EB77BFF0B1A}"/>
               </a:ext>
             </a:extLst>
           </p:cNvPr>
@@ -11593,7 +11593,7 @@
           <p:cNvPr id="9" name="">
             <a:extLst xmlns:a="http://schemas.openxmlformats.org/drawingml/2006/main">
               <a:ext uri="{FF2B5EF4-FFF2-40B4-BE49-F238E27FC236}">
-                <a16:creationId xmlns:a16="http://schemas.microsoft.com/office/drawing/2014/main" id="{A64C05CB-245D-42E9-9F58-24F7602B1A4D}"/>
+                <a16:creationId xmlns:a16="http://schemas.microsoft.com/office/drawing/2014/main" id="{3C369191-C672-417E-A520-C444A57C86D7}"/>
               </a:ext>
             </a:extLst>
           </p:cNvPr>
@@ -11747,7 +11747,7 @@
     </p:spTree>
     <p:extLst>
       <p:ext uri="{BB962C8B-B14F-4D97-AF65-F5344CB8AC3E}">
-        <p14:creationId xmlns:p14="http://schemas.microsoft.com/office/powerpoint/2010/main" val="1312387204"/>
+        <p14:creationId xmlns:p14="http://schemas.microsoft.com/office/powerpoint/2010/main" val="174527612"/>
       </p:ext>
     </p:extLst>
   </p:cSld>
@@ -11778,7 +11778,7 @@
           <p:cNvPr id="10" name="">
             <a:extLst xmlns:a="http://schemas.openxmlformats.org/drawingml/2006/main">
               <a:ext uri="{FF2B5EF4-FFF2-40B4-BE49-F238E27FC236}">
-                <a16:creationId xmlns:a16="http://schemas.microsoft.com/office/drawing/2014/main" id="{994ECE8E-1455-4B24-BE25-2C8F72DF0753}"/>
+                <a16:creationId xmlns:a16="http://schemas.microsoft.com/office/drawing/2014/main" id="{9048F71E-D947-44AD-8519-206FE2F51843}"/>
               </a:ext>
             </a:extLst>
           </p:cNvPr>
@@ -11934,7 +11934,7 @@
           <p:cNvPr id="2" name="">
             <a:extLst xmlns:a="http://schemas.openxmlformats.org/drawingml/2006/main">
               <a:ext uri="{FF2B5EF4-FFF2-40B4-BE49-F238E27FC236}">
-                <a16:creationId xmlns:a16="http://schemas.microsoft.com/office/drawing/2014/main" id="{5211E39C-FC10-4046-8009-91969ED2B41A}"/>
+                <a16:creationId xmlns:a16="http://schemas.microsoft.com/office/drawing/2014/main" id="{DE40C0A4-AB28-4870-838B-8B94E027E45D}"/>
               </a:ext>
             </a:extLst>
           </p:cNvPr>
@@ -12090,7 +12090,7 @@
           <p:cNvPr id="3" name="">
             <a:extLst xmlns:a="http://schemas.openxmlformats.org/drawingml/2006/main">
               <a:ext uri="{FF2B5EF4-FFF2-40B4-BE49-F238E27FC236}">
-                <a16:creationId xmlns:a16="http://schemas.microsoft.com/office/drawing/2014/main" id="{93B8E0A0-EA89-4C08-A062-48300D359545}"/>
+                <a16:creationId xmlns:a16="http://schemas.microsoft.com/office/drawing/2014/main" id="{05DBEFE6-588F-4E91-9CAF-AA815C3A2A60}"/>
               </a:ext>
             </a:extLst>
           </p:cNvPr>
@@ -12246,7 +12246,7 @@
           <p:cNvPr id="4" name="">
             <a:extLst xmlns:a="http://schemas.openxmlformats.org/drawingml/2006/main">
               <a:ext uri="{FF2B5EF4-FFF2-40B4-BE49-F238E27FC236}">
-                <a16:creationId xmlns:a16="http://schemas.microsoft.com/office/drawing/2014/main" id="{71A15EAA-94F8-4EB2-B9FC-AE3585330570}"/>
+                <a16:creationId xmlns:a16="http://schemas.microsoft.com/office/drawing/2014/main" id="{4CF0EA28-616C-421D-BE55-B9A560391B5E}"/>
               </a:ext>
             </a:extLst>
           </p:cNvPr>
@@ -12402,7 +12402,7 @@
           <p:cNvPr id="5" name="">
             <a:extLst xmlns:a="http://schemas.openxmlformats.org/drawingml/2006/main">
               <a:ext uri="{FF2B5EF4-FFF2-40B4-BE49-F238E27FC236}">
-                <a16:creationId xmlns:a16="http://schemas.microsoft.com/office/drawing/2014/main" id="{2282EA8C-54D2-44AF-83E7-CA9D14D7B3AD}"/>
+                <a16:creationId xmlns:a16="http://schemas.microsoft.com/office/drawing/2014/main" id="{7B15CFCD-3A79-441F-AC78-0BCB31983C4C}"/>
               </a:ext>
             </a:extLst>
           </p:cNvPr>
@@ -12558,7 +12558,7 @@
           <p:cNvPr id="6" name="">
             <a:extLst xmlns:a="http://schemas.openxmlformats.org/drawingml/2006/main">
               <a:ext uri="{FF2B5EF4-FFF2-40B4-BE49-F238E27FC236}">
-                <a16:creationId xmlns:a16="http://schemas.microsoft.com/office/drawing/2014/main" id="{E214C37C-AD9D-46D0-B242-C78823449EF3}"/>
+                <a16:creationId xmlns:a16="http://schemas.microsoft.com/office/drawing/2014/main" id="{103292DC-9384-464B-B6DE-966F56F4A2B6}"/>
               </a:ext>
             </a:extLst>
           </p:cNvPr>
@@ -12714,7 +12714,7 @@
           <p:cNvPr id="7" name="">
             <a:extLst xmlns:a="http://schemas.openxmlformats.org/drawingml/2006/main">
               <a:ext uri="{FF2B5EF4-FFF2-40B4-BE49-F238E27FC236}">
-                <a16:creationId xmlns:a16="http://schemas.microsoft.com/office/drawing/2014/main" id="{45E4DA90-52F9-4E02-B8FD-F101018AD286}"/>
+                <a16:creationId xmlns:a16="http://schemas.microsoft.com/office/drawing/2014/main" id="{66828EC2-197A-47C1-8FD3-09CBF114800D}"/>
               </a:ext>
             </a:extLst>
           </p:cNvPr>
@@ -12870,7 +12870,7 @@
           <p:cNvPr id="8" name="">
             <a:extLst xmlns:a="http://schemas.openxmlformats.org/drawingml/2006/main">
               <a:ext uri="{FF2B5EF4-FFF2-40B4-BE49-F238E27FC236}">
-                <a16:creationId xmlns:a16="http://schemas.microsoft.com/office/drawing/2014/main" id="{73D536FC-04CE-4FFA-9257-082444C1AF9C}"/>
+                <a16:creationId xmlns:a16="http://schemas.microsoft.com/office/drawing/2014/main" id="{5B612364-DAD7-4BA1-AEC2-5F5AAD26BE64}"/>
               </a:ext>
             </a:extLst>
           </p:cNvPr>
@@ -13016,7 +13016,7 @@
                 <a:ea typeface="Segoe UI"/>
                 <a:cs typeface="Segoe UI"/>
               </a:rPr>
-              <a:t>Phase 14 gate pending. Live fidelity and production readiness remain unverified.</a:t>
+              <a:t>Synthetic local scope. Live fidelity and production readiness remain unverified.</a:t>
             </a:r>
           </a:p>
         </p:txBody>
@@ -13026,7 +13026,7 @@
           <p:cNvPr id="9" name="">
             <a:extLst xmlns:a="http://schemas.openxmlformats.org/drawingml/2006/main">
               <a:ext uri="{FF2B5EF4-FFF2-40B4-BE49-F238E27FC236}">
-                <a16:creationId xmlns:a16="http://schemas.microsoft.com/office/drawing/2014/main" id="{F0E294ED-A9B9-43D2-BF4F-6D23682BD575}"/>
+                <a16:creationId xmlns:a16="http://schemas.microsoft.com/office/drawing/2014/main" id="{F75F70BB-5580-4B90-BDDA-DAF71FD385E4}"/>
               </a:ext>
             </a:extLst>
           </p:cNvPr>
@@ -13180,7 +13180,7 @@
     </p:spTree>
     <p:extLst>
       <p:ext uri="{BB962C8B-B14F-4D97-AF65-F5344CB8AC3E}">
-        <p14:creationId xmlns:p14="http://schemas.microsoft.com/office/powerpoint/2010/main" val="1469547688"/>
+        <p14:creationId xmlns:p14="http://schemas.microsoft.com/office/powerpoint/2010/main" val="2006572679"/>
       </p:ext>
     </p:extLst>
   </p:cSld>
@@ -13211,7 +13211,7 @@
           <p:cNvPr id="10" name="">
             <a:extLst xmlns:a="http://schemas.openxmlformats.org/drawingml/2006/main">
               <a:ext uri="{FF2B5EF4-FFF2-40B4-BE49-F238E27FC236}">
-                <a16:creationId xmlns:a16="http://schemas.microsoft.com/office/drawing/2014/main" id="{12BE1D86-50C8-43D6-96B9-26F1782EBF90}"/>
+                <a16:creationId xmlns:a16="http://schemas.microsoft.com/office/drawing/2014/main" id="{A721D05D-E4B3-436C-886C-F1D81AFFC4E1}"/>
               </a:ext>
             </a:extLst>
           </p:cNvPr>
@@ -13367,7 +13367,7 @@
           <p:cNvPr id="2" name="">
             <a:extLst xmlns:a="http://schemas.openxmlformats.org/drawingml/2006/main">
               <a:ext uri="{FF2B5EF4-FFF2-40B4-BE49-F238E27FC236}">
-                <a16:creationId xmlns:a16="http://schemas.microsoft.com/office/drawing/2014/main" id="{F9D8CC69-C1A3-4918-A2D6-F2444F49A354}"/>
+                <a16:creationId xmlns:a16="http://schemas.microsoft.com/office/drawing/2014/main" id="{90E4F6AC-8FE6-44A2-B029-88E2F39A3FBF}"/>
               </a:ext>
             </a:extLst>
           </p:cNvPr>
@@ -13523,7 +13523,7 @@
           <p:cNvPr id="3" name="">
             <a:extLst xmlns:a="http://schemas.openxmlformats.org/drawingml/2006/main">
               <a:ext uri="{FF2B5EF4-FFF2-40B4-BE49-F238E27FC236}">
-                <a16:creationId xmlns:a16="http://schemas.microsoft.com/office/drawing/2014/main" id="{AC2D964E-C3DC-4263-B392-DA620A437AE3}"/>
+                <a16:creationId xmlns:a16="http://schemas.microsoft.com/office/drawing/2014/main" id="{20640A94-3AC6-4475-A797-8761DF5AE233}"/>
               </a:ext>
             </a:extLst>
           </p:cNvPr>
@@ -13679,7 +13679,7 @@
           <p:cNvPr id="4" name="">
             <a:extLst xmlns:a="http://schemas.openxmlformats.org/drawingml/2006/main">
               <a:ext uri="{FF2B5EF4-FFF2-40B4-BE49-F238E27FC236}">
-                <a16:creationId xmlns:a16="http://schemas.microsoft.com/office/drawing/2014/main" id="{13F3FE95-C6C1-4599-90AD-CE450EDB9D2F}"/>
+                <a16:creationId xmlns:a16="http://schemas.microsoft.com/office/drawing/2014/main" id="{B0B0CD83-6B99-4BF1-B438-EFC90C60A367}"/>
               </a:ext>
             </a:extLst>
           </p:cNvPr>
@@ -13835,7 +13835,7 @@
           <p:cNvPr id="5" name="">
             <a:extLst xmlns:a="http://schemas.openxmlformats.org/drawingml/2006/main">
               <a:ext uri="{FF2B5EF4-FFF2-40B4-BE49-F238E27FC236}">
-                <a16:creationId xmlns:a16="http://schemas.microsoft.com/office/drawing/2014/main" id="{D4E21339-448D-4D6E-AAEF-E6EF48DC41A0}"/>
+                <a16:creationId xmlns:a16="http://schemas.microsoft.com/office/drawing/2014/main" id="{B8239AC9-8E0A-4FF9-8D09-3EE7A827DA7C}"/>
               </a:ext>
             </a:extLst>
           </p:cNvPr>
@@ -13991,7 +13991,7 @@
           <p:cNvPr id="6" name="">
             <a:extLst xmlns:a="http://schemas.openxmlformats.org/drawingml/2006/main">
               <a:ext uri="{FF2B5EF4-FFF2-40B4-BE49-F238E27FC236}">
-                <a16:creationId xmlns:a16="http://schemas.microsoft.com/office/drawing/2014/main" id="{8F70CC8C-811D-4429-A6E8-2AA6DB8B08BF}"/>
+                <a16:creationId xmlns:a16="http://schemas.microsoft.com/office/drawing/2014/main" id="{C8146D53-EE3B-4438-BA08-63A27260C6D1}"/>
               </a:ext>
             </a:extLst>
           </p:cNvPr>
@@ -14147,7 +14147,7 @@
           <p:cNvPr id="7" name="">
             <a:extLst xmlns:a="http://schemas.openxmlformats.org/drawingml/2006/main">
               <a:ext uri="{FF2B5EF4-FFF2-40B4-BE49-F238E27FC236}">
-                <a16:creationId xmlns:a16="http://schemas.microsoft.com/office/drawing/2014/main" id="{1D019F8A-BCD8-4F41-B6EF-612D30757FFC}"/>
+                <a16:creationId xmlns:a16="http://schemas.microsoft.com/office/drawing/2014/main" id="{562CDCE7-1BA0-4097-800A-73F77D5A2078}"/>
               </a:ext>
             </a:extLst>
           </p:cNvPr>
@@ -14303,7 +14303,7 @@
           <p:cNvPr id="8" name="">
             <a:extLst xmlns:a="http://schemas.openxmlformats.org/drawingml/2006/main">
               <a:ext uri="{FF2B5EF4-FFF2-40B4-BE49-F238E27FC236}">
-                <a16:creationId xmlns:a16="http://schemas.microsoft.com/office/drawing/2014/main" id="{88606959-E43C-441A-ACE9-AFB2BE718692}"/>
+                <a16:creationId xmlns:a16="http://schemas.microsoft.com/office/drawing/2014/main" id="{B7A7E52A-021F-4E89-A680-F8BC1CECAE65}"/>
               </a:ext>
             </a:extLst>
           </p:cNvPr>
@@ -14459,7 +14459,7 @@
           <p:cNvPr id="9" name="">
             <a:extLst xmlns:a="http://schemas.openxmlformats.org/drawingml/2006/main">
               <a:ext uri="{FF2B5EF4-FFF2-40B4-BE49-F238E27FC236}">
-                <a16:creationId xmlns:a16="http://schemas.microsoft.com/office/drawing/2014/main" id="{D4BF599F-28D1-47C9-9013-2D3D8E1FD80B}"/>
+                <a16:creationId xmlns:a16="http://schemas.microsoft.com/office/drawing/2014/main" id="{7EC7AE29-8EB2-48B6-BB71-58D5709784D2}"/>
               </a:ext>
             </a:extLst>
           </p:cNvPr>
@@ -14613,7 +14613,7 @@
     </p:spTree>
     <p:extLst>
       <p:ext uri="{BB962C8B-B14F-4D97-AF65-F5344CB8AC3E}">
-        <p14:creationId xmlns:p14="http://schemas.microsoft.com/office/powerpoint/2010/main" val="1210384290"/>
+        <p14:creationId xmlns:p14="http://schemas.microsoft.com/office/powerpoint/2010/main" val="1669897788"/>
       </p:ext>
     </p:extLst>
   </p:cSld>

</xml_diff>